<commit_message>
Transition to db assets
</commit_message>
<xml_diff>
--- a/public/pptx/king_of_kings.pptx
+++ b/public/pptx/king_of_kings.pptx
@@ -226,7 +226,7 @@
           <a:p>
             <a:fld id="{8E0C8564-6808-44A5-9BA0-31DD0C4EAFF4}" type="datetimeFigureOut">
               <a:rPr lang="en-CA" smtClean="0"/>
-              <a:t>2022-03-31</a:t>
+              <a:t>2026-03-06</a:t>
             </a:fld>
             <a:endParaRPr lang="en-CA"/>
           </a:p>
@@ -6849,7 +6849,7 @@
             </a:pPr>
             <a:r>
               <a:rPr lang="en-US" altLang="ko-KR" sz="5870" dirty="0"/>
-              <a:t>By the power of his blood,</a:t>
+              <a:t>By His blood and in His name</a:t>
             </a:r>
           </a:p>
           <a:p>
@@ -6864,7 +6864,7 @@
             </a:pPr>
             <a:r>
               <a:rPr lang="en-US" altLang="ko-KR" sz="5870" dirty="0"/>
-              <a:t>he has set all nations free</a:t>
+              <a:t>In His freedom I am free</a:t>
             </a:r>
           </a:p>
           <a:p>
@@ -6974,7 +6974,7 @@
             </a:pPr>
             <a:r>
               <a:rPr lang="en-US" altLang="ko-KR" sz="5870" dirty="0"/>
-              <a:t>Every nation shall rejoice </a:t>
+              <a:t>For the love of Jesus Christ</a:t>
             </a:r>
           </a:p>
           <a:p>
@@ -6989,7 +6989,7 @@
             </a:pPr>
             <a:r>
               <a:rPr lang="en-US" altLang="ko-KR" sz="5870" dirty="0"/>
-              <a:t>and bow before the King of kings</a:t>
+              <a:t>Who has resurrected me</a:t>
             </a:r>
           </a:p>
           <a:p>

</xml_diff>